<commit_message>
NDRC team slide: trim Conor's bio, add the promotion model
The granular list (case_id enforcement, verified-fact split, RBAC, LOD rendering)
was too much for a slide and reciting it sounds defensive. Cut to the two things
that carry: he is the architect of the case model, and he wrote the first commit.
The initial-commit fact is kept in the pack as backing if it is ever probed.

Added what was missing — he drives the enterprise platform, while features are
proven on live casework first and promoted once they mature. That is a real
engineering-discipline signal: nothing reaches the deployable product until it has
survived a real matter.

Stated without version numbers on purpose. The house rule is one product, and the
promotion discipline stands on its own — said as engineering judgement it reads as
rigour, said as v1/v2 it reads as an unfinished product. Recorded in the pack so it
does not get reintroduced.

Co-Authored-By: Claude Opus 5 (1M context) <noreply@anthropic.com>
</commit_message>
<xml_diff>
--- a/Loupe-NDRC-deck.pptx
+++ b/Loupe-NDRC-deck.pptx
@@ -10127,7 +10127,25 @@
                 </a:solidFill>
                 <a:latin typeface="IBM Plex Sans"/>
               </a:rPr>
-              <a:t> The approach the platform rests on is his: extract entities and events from evidence with an LLM at ingestion, resolve them into a graph, and query that concrete structure afterwards — so an answer is a traversal over modelled evidence, not a retrieval over text. He wrote the first commit — LLM client, graph client and ingestion pipeline — and 240+ since: case-level isolation enforced in the database, entity resolution, the split between verified facts and AI inference, and the performance work that keeps very large cases traversable.</a:t>
+              <a:t> The approach the platform rests on is his: extract entities and events from evidence with an LLM at ingestion, resolve them into a graph, and query that concrete structure afterwards — so an answer is a traversal over modelled evidence, not a retrieval over text. He wrote the first commit and has led engineering since. </a:t>
+            </a:r>
+            <a:r>
+              <a:rPr sz="1100" b="1" i="0">
+                <a:solidFill>
+                  <a:srgbClr val="9A9DA5"/>
+                </a:solidFill>
+                <a:latin typeface="IBM Plex Sans"/>
+              </a:rPr>
+              <a:t>Drives the enterprise platform</a:t>
+            </a:r>
+            <a:r>
+              <a:rPr sz="1100" b="0" i="0">
+                <a:solidFill>
+                  <a:srgbClr val="9A9DA5"/>
+                </a:solidFill>
+                <a:latin typeface="IBM Plex Sans"/>
+              </a:rPr>
+              <a:t>, while features are proven on live casework first and promoted once they mature — so nothing reaches the deployable product until it has survived a real matter.</a:t>
             </a:r>
           </a:p>
           <a:p>

</xml_diff>

<commit_message>
Repeat the dollar sign on the second figure of every range in the deck
Applies the same rule to the slides: $38k–$139k, $3,650 – $8,450,
$34,200 – $130,575, $37,850 – $139,025, $15,650 – $20,450,
$22,000–$119,000, $0.6M–$1.4M, $2.5M–$7.5M. Where a magnitude suffix is
shared it is repeated too, since "$38–139k" has the same ambiguity.

Speaker notes are left in their shorthand. Deck regenerated; the rebuilt PDF
differs from the previous one by these figures alone, twelve pages before
and after.

Co-Authored-By: Claude Opus 5 (1M context) <noreply@anthropic.com>
</commit_message>
<xml_diff>
--- a/Loupe-NDRC-deck.pptx
+++ b/Loupe-NDRC-deck.pptx
@@ -10912,7 +10912,7 @@
                 </a:solidFill>
                 <a:latin typeface="IBM Plex Sans"/>
               </a:rPr>
-              <a:t>Four funded companies selling AI to criminal defence, $2.5–7.5M seed each, with the bar associations and the certifications. </a:t>
+              <a:t>Four funded companies selling AI to criminal defence, $2.5M–$7.5M seed each, with the bar associations and the certifications. </a:t>
             </a:r>
             <a:r>
               <a:rPr sz="1100" b="1" i="0">
@@ -11702,8 +11702,8 @@
                 </a:solidFill>
                 <a:latin typeface="Space Grotesk"/>
               </a:rPr>
-              <a:t>Today a serious case costs $38–139k.
-With Loupe, $16–20k.</a:t>
+              <a:t>Today a serious case costs $38k–$139k.
+With Loupe, $16k–$20k.</a:t>
             </a:r>
           </a:p>
         </p:txBody>
@@ -11978,7 +11978,7 @@
                           </a:solidFill>
                           <a:latin typeface="IBM Plex Sans"/>
                         </a:rPr>
-                        <a:t>$3,650 – 8,450</a:t>
+                        <a:t>$3,650 – $8,450</a:t>
                       </a:r>
                     </a:p>
                   </a:txBody>
@@ -12011,7 +12011,7 @@
                           </a:solidFill>
                           <a:latin typeface="IBM Plex Sans"/>
                         </a:rPr>
-                        <a:t>$3,650 – 8,450</a:t>
+                        <a:t>$3,650 – $8,450</a:t>
                       </a:r>
                     </a:p>
                   </a:txBody>
@@ -12079,7 +12079,7 @@
                           </a:solidFill>
                           <a:latin typeface="IBM Plex Sans"/>
                         </a:rPr>
-                        <a:t>$34,200 – 130,575</a:t>
+                        <a:t>$34,200 – $130,575</a:t>
                       </a:r>
                     </a:p>
                   </a:txBody>
@@ -12281,7 +12281,7 @@
                           </a:solidFill>
                           <a:latin typeface="IBM Plex Sans"/>
                         </a:rPr>
-                        <a:t>$37,850 – 139,025</a:t>
+                        <a:t>$37,850 – $139,025</a:t>
                       </a:r>
                     </a:p>
                   </a:txBody>
@@ -12314,7 +12314,7 @@
                           </a:solidFill>
                           <a:latin typeface="IBM Plex Sans"/>
                         </a:rPr>
-                        <a:t>$15,650 – 20,450</a:t>
+                        <a:t>$15,650 – $20,450</a:t>
                       </a:r>
                     </a:p>
                   </a:txBody>
@@ -12470,7 +12470,7 @@
                 </a:solidFill>
                 <a:latin typeface="IBM Plex Sans"/>
               </a:rPr>
-              <a:t>Saved: $22,000–119,000 and 29–50 hours per case.</a:t>
+              <a:t>Saved: $22,000–$119,000 and 29–50 hours per case.</a:t>
             </a:r>
             <a:r>
               <a:rPr sz="1600" b="0" i="0">
@@ -12488,7 +12488,7 @@
                 </a:solidFill>
                 <a:latin typeface="IBM Plex Sans"/>
               </a:rPr>
-              <a:t>$0.6–1.4M and 550–1,150 hours returned.</a:t>
+              <a:t>$0.6M–$1.4M and 550–1,150 hours returned.</a:t>
             </a:r>
           </a:p>
           <a:p>

</xml_diff>